<commit_message>
docs(tv5): integrate TV3 handoff and verify submission package
</commit_message>
<xml_diff>
--- a/Bo_nop_Nhom06/slides/Nhom06_ThuyetTrinh_15_Slides.pptx
+++ b/Bo_nop_Nhom06/slides/Nhom06_ThuyetTrinh_15_Slides.pptx
@@ -1356,12 +1356,42 @@
           <a:lstStyle xmlns:a="http://schemas.openxmlformats.org/drawingml/2006/main"/>
           <a:p xmlns:a="http://schemas.openxmlformats.org/drawingml/2006/main">
             <a:r>
-              <a:t>Đạt phụ trách hai bảng khoản phát sinh và các constraint. Tháng1–12, năm&gt;=2020, SoTien&gt;=0, FK nhân viên. Không có UNIQUE tên khoản/nhân viên/kỳ, nhiều khoản cùng tên có thể hợp lệ; không trình bày chống trùng chưa cài. Nguồn module03.</a:t>
-            </a:r>
-          </a:p>
-          <a:p xmlns:a="http://schemas.openxmlformats.org/drawingml/2006/main">
-            <a:r>
-              <a:t>Nguồn: docs/TV3_Huong_Dan_Thuyet_Trinh.md, phân công docs/Ke_hoach_phan_cong_Project_DBMS_Nhom06.md. Mốc nói: 04:00–06:00.</a:t>
+              <a:t>Slide 7 — Dữ liệu phụ cấp và khấu trừ</a:t>
+            </a:r>
+          </a:p>
+          <a:p xmlns:a="http://schemas.openxmlformats.org/drawingml/2006/main">
+            <a:r>
+              <a:t>Ý chính trên slide: Hai bảng theo nhân viên và kỳ; khóa ngoại; CHECK tiền/tháng/năm; không có quy tắc UNIQUE theo tên khoản.</a:t>
+            </a:r>
+          </a:p>
+          <a:p xmlns:a="http://schemas.openxmlformats.org/drawingml/2006/main">
+            <a:r>
+              <a:t/>
+            </a:r>
+          </a:p>
+          <a:p xmlns:a="http://schemas.openxmlformats.org/drawingml/2006/main">
+            <a:r>
+              <a:t>Lời nói (40 giây):</a:t>
+            </a:r>
+          </a:p>
+          <a:p xmlns:a="http://schemas.openxmlformats.org/drawingml/2006/main">
+            <a:r>
+              <a:t/>
+            </a:r>
+          </a:p>
+          <a:p xmlns:a="http://schemas.openxmlformats.org/drawingml/2006/main">
+            <a:r>
+              <a:t>“Phần của em là phụ cấp và khấu trừ theo từng nhân viên trong từng kỳ lương. Hai bảng lưu khoản phát sinh riêng, liên kết nhân viên bằng khóa ngoại nên không tạo dữ liệu mồ côi. CHECK chặn số tiền âm, tháng ngoài 1 đến 12 và năm trước 2020. Một nhân viên có thể có nhiều khoản cùng kỳ; tên khoản không phải khóa duy nhất. Dữ liệu này là đầu vào để tính thực nhận: tiền công cộng tổng phụ cấp rồi trừ tổng khấu trừ.”</a:t>
+            </a:r>
+          </a:p>
+          <a:p xmlns:a="http://schemas.openxmlformats.org/drawingml/2006/main">
+            <a:r>
+              <a:t/>
+            </a:r>
+          </a:p>
+          <a:p xmlns:a="http://schemas.openxmlformats.org/drawingml/2006/main">
+            <a:r>
+              <a:t>TV5 tích hợp 15/10/2026 từ PR #43/#48. Đường dẫn tính từ thư mục slides/ trong package. Biên nhận: ../evidence/TV3/README_EVIDENCE.md.</a:t>
             </a:r>
           </a:p>
         </p:txBody>
@@ -1431,12 +1461,42 @@
           <a:lstStyle xmlns:a="http://schemas.openxmlformats.org/drawingml/2006/main"/>
           <a:p xmlns:a="http://schemas.openxmlformats.org/drawingml/2006/main">
             <a:r>
-              <a:t>fn_TongKhauTru, vw_TongPhuCapThang thuộc TV3. Trigger phụ cấp bảo vệ kỳ chốt có thể nằm module05 nhưng ownership theo phân công. sp_XoaKyLuongChuaChot khóa header, kiểm CHUA_CHOT rồi xóa chi tiết trước header trong transaction, lỗi rollback. Admin/Payroll được xóa kỳ, HR không. Index IX_PHUCAP_MaNV_ThangNam include SoTien.</a:t>
-            </a:r>
-          </a:p>
-          <a:p xmlns:a="http://schemas.openxmlformats.org/drawingml/2006/main">
-            <a:r>
-              <a:t>Nguồn: docs/TV3_Huong_Dan_Thuyet_Trinh.md, phân công docs/Ke_hoach_phan_cong_Project_DBMS_Nhom06.md. Mốc nói: 04:00–06:00.</a:t>
+              <a:t>Slide 8 — Tổng hợp và bảo vệ kỳ lương</a:t>
+            </a:r>
+          </a:p>
+          <a:p xmlns:a="http://schemas.openxmlformats.org/drawingml/2006/main">
+            <a:r>
+              <a:t>Ý chính trên slide: Function/View tổng hợp; trigger chặn kỳ đã chốt; procedure xóa kỳ nháp trong transaction; index phục vụ lọc.</a:t>
+            </a:r>
+          </a:p>
+          <a:p xmlns:a="http://schemas.openxmlformats.org/drawingml/2006/main">
+            <a:r>
+              <a:t/>
+            </a:r>
+          </a:p>
+          <a:p xmlns:a="http://schemas.openxmlformats.org/drawingml/2006/main">
+            <a:r>
+              <a:t>Lời nói (45 giây):</a:t>
+            </a:r>
+          </a:p>
+          <a:p xmlns:a="http://schemas.openxmlformats.org/drawingml/2006/main">
+            <a:r>
+              <a:t/>
+            </a:r>
+          </a:p>
+          <a:p xmlns:a="http://schemas.openxmlformats.org/drawingml/2006/main">
+            <a:r>
+              <a:t>“fn_TongKhauTru trả tổng khấu trừ của một nhân viên trong một tháng, còn vw_TongPhuCapThang gom số khoản và tổng tiền để tra cứu. Khi kỳ đã chốt, trigger ở module bảo mật khóa dòng kỳ cha bằng UPDLOCK, HOLDLOCK và kiểm tra cả dữ liệu cũ lẫn mới, nên sửa, xóa hoặc chuyển khoản sang kỳ chốt đều bị từ chối. Khi xóa kỳ nháp, sp_XoaKyLuongChuaChot mở transaction, khóa kỳ, xóa chi tiết trước bảng lương và rollback nếu có lỗi. Index phụ cấp hỗ trợ lọc theo nhân viên và kỳ.”</a:t>
+            </a:r>
+          </a:p>
+          <a:p xmlns:a="http://schemas.openxmlformats.org/drawingml/2006/main">
+            <a:r>
+              <a:t/>
+            </a:r>
+          </a:p>
+          <a:p xmlns:a="http://schemas.openxmlformats.org/drawingml/2006/main">
+            <a:r>
+              <a:t>TV5 tích hợp 15/10/2026 từ PR #43/#48. Đường dẫn tính từ thư mục slides/ trong package. Biên nhận: ../evidence/TV3/README_EVIDENCE.md.</a:t>
             </a:r>
           </a:p>
         </p:txBody>
@@ -1506,12 +1566,72 @@
           <a:lstStyle xmlns:a="http://schemas.openxmlformats.org/drawingml/2006/main"/>
           <a:p xmlns:a="http://schemas.openxmlformats.org/drawingml/2006/main">
             <a:r>
-              <a:t>Source panel PhuCapKhauTruPanel gọi service/DAO và SP phù hợp role. Chỉ SQL là lớp bảo vệ cuối. Benchmark642→2 thuộc log lịch sử08/10/2026, fixture30.000 dòng7targetsum6.300.000, hints ép scan/seek. Không lấy timestamp mới của package làm ngày đo. PR43 notes có P2 cũ nên deck này dùng guide/source đúng Đạt. Evidence nguyên bản giữ riêng.</a:t>
-            </a:r>
-          </a:p>
-          <a:p xmlns:a="http://schemas.openxmlformats.org/drawingml/2006/main">
-            <a:r>
-              <a:t>Nguồn: docs/TV3_Huong_Dan_Thuyet_Trinh.md, phân công docs/Ke_hoach_phan_cong_Project_DBMS_Nhom06.md. Mốc nói: 04:00–06:00.</a:t>
+              <a:t>Slide 9 — Giao diện và minh chứng</a:t>
+            </a:r>
+          </a:p>
+          <a:p xmlns:a="http://schemas.openxmlformats.org/drawingml/2006/main">
+            <a:r>
+              <a:t>Ý chính trên slide: Giao diện lọc theo tháng/năm; QA SQL xác nhận function/view, constraint và xóa kỳ; benchmark fixture riêng.</a:t>
+            </a:r>
+          </a:p>
+          <a:p xmlns:a="http://schemas.openxmlformats.org/drawingml/2006/main">
+            <a:r>
+              <a:t/>
+            </a:r>
+          </a:p>
+          <a:p xmlns:a="http://schemas.openxmlformats.org/drawingml/2006/main">
+            <a:r>
+              <a:t>Lời nói (35 giây):</a:t>
+            </a:r>
+          </a:p>
+          <a:p xmlns:a="http://schemas.openxmlformats.org/drawingml/2006/main">
+            <a:r>
+              <a:t/>
+            </a:r>
+          </a:p>
+          <a:p xmlns:a="http://schemas.openxmlformats.org/drawingml/2006/main">
+            <a:r>
+              <a:t>“Trên giao diện, người dùng chọn kỳ, xem hai danh sách và tổng hợp phụ cấp. HR và Payroll được thao tác phụ cấp, khấu trừ theo quyền; xóa kỳ chỉ dành cho Admin hoặc Payroll. Bộ kiểm thử SQL TV3 chạy ngày 13/10/2026 (lưu tại ../evidence/TV3/Minh_chung/Log_SQLPlan/test_module_phucap_khautru_TV3.log) đã xác nhận PASS 4 cụm: function/view, chặn CHECK tiền âm và tháng sai, xóa kỳ nháp 5/2020, từ chối kỳ đã chốt 6/2020 và cleanup fixture. Benchmark 30 nghìn dòng trên bảng tạm #PHUCAP_BENCHMARK lượt chạy ngày 13/10/2026 (lưu tại ../evidence/TV3/Minh_chung/Log_SQLPlan/benchmark_test_benchmark_index_TV3.log và TV3_ActualPlan.sqlplan) ghi nhận giảm từ 642 logical reads xuống còn 2 logical reads sau khi tạo index; đây là phép đo trên fixture riêng, không phải cam kết cho mọi máy. Các ảnh tại ../evidence/TV3/Minh_chung/Screenshots/ chỉ dùng làm tư liệu minh họa lịch sử. Em xin chuyển phần tính lương cho TV4.”</a:t>
+            </a:r>
+          </a:p>
+          <a:p xmlns:a="http://schemas.openxmlformats.org/drawingml/2006/main">
+            <a:r>
+              <a:t/>
+            </a:r>
+          </a:p>
+          <a:p xmlns:a="http://schemas.openxmlformats.org/drawingml/2006/main">
+            <a:r>
+              <a:t>Đường dẫn file bằng chứng cho người ghép deck (lượt chạy 13/10/2026):</a:t>
+            </a:r>
+          </a:p>
+          <a:p xmlns:a="http://schemas.openxmlformats.org/drawingml/2006/main">
+            <a:r>
+              <a:t>- Log kiểm thử module (13/10/2026): ../evidence/TV3/Minh_chung/Log_SQLPlan/test_module_phucap_khautru_TV3.log</a:t>
+            </a:r>
+          </a:p>
+          <a:p xmlns:a="http://schemas.openxmlformats.org/drawingml/2006/main">
+            <a:r>
+              <a:t>- Log benchmark (13/10/2026): ../evidence/TV3/Minh_chung/Log_SQLPlan/benchmark_test_benchmark_index_TV3.log</a:t>
+            </a:r>
+          </a:p>
+          <a:p xmlns:a="http://schemas.openxmlformats.org/drawingml/2006/main">
+            <a:r>
+              <a:t>- Actual Execution Plan (13/10/2026): ../evidence/TV3/Minh_chung/Log_SQLPlan/TV3_ActualPlan.sqlplan</a:t>
+            </a:r>
+          </a:p>
+          <a:p xmlns:a="http://schemas.openxmlformats.org/drawingml/2006/main">
+            <a:r>
+              <a:t>- Ảnh minh họa lịch sử (30/09–06/10/2026): ../evidence/TV3/Minh_chung/Screenshots/</a:t>
+            </a:r>
+          </a:p>
+          <a:p xmlns:a="http://schemas.openxmlformats.org/drawingml/2006/main">
+            <a:r>
+              <a:t/>
+            </a:r>
+          </a:p>
+          <a:p xmlns:a="http://schemas.openxmlformats.org/drawingml/2006/main">
+            <a:r>
+              <a:t>TV5 tích hợp 15/10/2026 từ PR #43/#48. Đường dẫn tính từ thư mục slides/ trong package. Biên nhận: ../evidence/TV3/README_EVIDENCE.md.</a:t>
             </a:r>
           </a:p>
         </p:txBody>

</xml_diff>

<commit_message>
docs(package): dong bo word/slide, bo sung evidence option b tv2 va cap nhat manifest
</commit_message>
<xml_diff>
--- a/Bo_nop_Nhom06/slides/Nhom06_ThuyetTrinh_15_Slides.pptx
+++ b/Bo_nop_Nhom06/slides/Nhom06_ThuyetTrinh_15_Slides.pptx
@@ -2,27 +2,27 @@
 <file path=ppt/presentation.xml><?xml version="1.0" encoding="utf-8"?>
 <p:presentation xmlns:p="http://schemas.openxmlformats.org/presentationml/2006/main">
   <p:sldMasterIdLst>
-    <p:sldMasterId xmlns:r="http://schemas.openxmlformats.org/officeDocument/2006/relationships" id="2147483648" r:id="Rde5c449eadcd432d"/>
+    <p:sldMasterId xmlns:r="http://schemas.openxmlformats.org/officeDocument/2006/relationships" id="2147483648" r:id="Rf5ee34ec451043f2"/>
   </p:sldMasterIdLst>
   <p:notesMasterIdLst>
-    <p:notesMasterId xmlns:r="http://schemas.openxmlformats.org/officeDocument/2006/relationships" r:id="R7885b56d77f84bfe"/>
+    <p:notesMasterId xmlns:r="http://schemas.openxmlformats.org/officeDocument/2006/relationships" r:id="R93cdf9f976664ae9"/>
   </p:notesMasterIdLst>
   <p:sldIdLst>
-    <p:sldId xmlns:r="http://schemas.openxmlformats.org/officeDocument/2006/relationships" id="256" r:id="R39d63f780f7f4f88"/>
-    <p:sldId xmlns:r="http://schemas.openxmlformats.org/officeDocument/2006/relationships" id="257" r:id="R81b87eea164d425b"/>
-    <p:sldId xmlns:r="http://schemas.openxmlformats.org/officeDocument/2006/relationships" id="258" r:id="Ref0a12f1e6314a5c"/>
-    <p:sldId xmlns:r="http://schemas.openxmlformats.org/officeDocument/2006/relationships" id="259" r:id="R5a58295f4be64ec9"/>
-    <p:sldId xmlns:r="http://schemas.openxmlformats.org/officeDocument/2006/relationships" id="260" r:id="Rdbab148b9f88451f"/>
-    <p:sldId xmlns:r="http://schemas.openxmlformats.org/officeDocument/2006/relationships" id="261" r:id="R288526c4d90945d0"/>
-    <p:sldId xmlns:r="http://schemas.openxmlformats.org/officeDocument/2006/relationships" id="262" r:id="R5dc0d5cebb9b4c0e"/>
-    <p:sldId xmlns:r="http://schemas.openxmlformats.org/officeDocument/2006/relationships" id="263" r:id="R6b9da83a29ef4f2a"/>
-    <p:sldId xmlns:r="http://schemas.openxmlformats.org/officeDocument/2006/relationships" id="264" r:id="R5f7bd942b319400c"/>
-    <p:sldId xmlns:r="http://schemas.openxmlformats.org/officeDocument/2006/relationships" id="265" r:id="R28850fad77e349e0"/>
-    <p:sldId xmlns:r="http://schemas.openxmlformats.org/officeDocument/2006/relationships" id="266" r:id="R18c2d96d54d441d6"/>
-    <p:sldId xmlns:r="http://schemas.openxmlformats.org/officeDocument/2006/relationships" id="267" r:id="R4e3b7e758aa84b37"/>
-    <p:sldId xmlns:r="http://schemas.openxmlformats.org/officeDocument/2006/relationships" id="268" r:id="Re2ce48e77c4b417a"/>
-    <p:sldId xmlns:r="http://schemas.openxmlformats.org/officeDocument/2006/relationships" id="269" r:id="R22036a1ce78d4acc"/>
-    <p:sldId xmlns:r="http://schemas.openxmlformats.org/officeDocument/2006/relationships" id="270" r:id="R982d20a8dfd847ff"/>
+    <p:sldId xmlns:r="http://schemas.openxmlformats.org/officeDocument/2006/relationships" id="256" r:id="Ra088389441c94877"/>
+    <p:sldId xmlns:r="http://schemas.openxmlformats.org/officeDocument/2006/relationships" id="257" r:id="R12805d85f043452f"/>
+    <p:sldId xmlns:r="http://schemas.openxmlformats.org/officeDocument/2006/relationships" id="258" r:id="R95c54aa372bf4446"/>
+    <p:sldId xmlns:r="http://schemas.openxmlformats.org/officeDocument/2006/relationships" id="259" r:id="Rd3cde03afc874b7e"/>
+    <p:sldId xmlns:r="http://schemas.openxmlformats.org/officeDocument/2006/relationships" id="260" r:id="Rb06d57608cfc4ce2"/>
+    <p:sldId xmlns:r="http://schemas.openxmlformats.org/officeDocument/2006/relationships" id="261" r:id="R4090d3af7876450e"/>
+    <p:sldId xmlns:r="http://schemas.openxmlformats.org/officeDocument/2006/relationships" id="262" r:id="R91c39d8ff519478c"/>
+    <p:sldId xmlns:r="http://schemas.openxmlformats.org/officeDocument/2006/relationships" id="263" r:id="Ra54940dce21644c8"/>
+    <p:sldId xmlns:r="http://schemas.openxmlformats.org/officeDocument/2006/relationships" id="264" r:id="Rb59910fb1f344c60"/>
+    <p:sldId xmlns:r="http://schemas.openxmlformats.org/officeDocument/2006/relationships" id="265" r:id="R4b50a6bdda3b4ec1"/>
+    <p:sldId xmlns:r="http://schemas.openxmlformats.org/officeDocument/2006/relationships" id="266" r:id="Rb7c7c996668644cc"/>
+    <p:sldId xmlns:r="http://schemas.openxmlformats.org/officeDocument/2006/relationships" id="267" r:id="R6ebe933693144e3e"/>
+    <p:sldId xmlns:r="http://schemas.openxmlformats.org/officeDocument/2006/relationships" id="268" r:id="R4c70c1d8925d45c0"/>
+    <p:sldId xmlns:r="http://schemas.openxmlformats.org/officeDocument/2006/relationships" id="269" r:id="Rc29a02bf02a24658"/>
+    <p:sldId xmlns:r="http://schemas.openxmlformats.org/officeDocument/2006/relationships" id="270" r:id="R6c4d60ea0fed444d"/>
   </p:sldIdLst>
   <p:sldSz cx="12192000" cy="6858000"/>
   <p:notesSz cx="6858000" cy="9144000"/>
@@ -986,6 +986,11 @@
           </a:p>
           <a:p xmlns:a="http://schemas.openxmlformats.org/drawingml/2006/main">
             <a:r>
+              <a:t>Bản chi tiết TV1 đã bàn giao qua PR #51: ../evidence/TV1/TV1_Phan_Bao_Cao.docx, ../evidence/TV1/TV1_Slides_1-3.pptx và ../evidence/TV1/README_EVIDENCE.md. Deck nhóm giữ bản tóm tắt phù hợp giới hạn 15 slide.</a:t>
+            </a:r>
+          </a:p>
+          <a:p xmlns:a="http://schemas.openxmlformats.org/drawingml/2006/main">
+            <a:r>
               <a:t>Nguồn: docs/TV1_Huong_Dan_Thuyet_Trinh.md, phân công docs/Ke_hoach_phan_cong_Project_DBMS_Nhom06.md. Mốc nói: 00:00–02:00.</a:t>
             </a:r>
           </a:p>
@@ -1061,6 +1066,11 @@
           </a:p>
           <a:p xmlns:a="http://schemas.openxmlformats.org/drawingml/2006/main">
             <a:r>
+              <a:t>Bàn giao TV1 qua PR #51: ../evidence/TV1/Minh_chung/test_module_nhansu_TV1.log (7/7), ../evidence/TV5/age-boundaries-20261013/TV1_Age_Boundaries.sql.messages.log (9 ca/18 thao tác), ../evidence/TV1/Minh_chung/benchmark_test_benchmark_index_TV1.log và ../evidence/TV1/Minh_chung/TV1_Benchmark_ActualPlan.sqlplan (75→10 reads).</a:t>
+            </a:r>
+          </a:p>
+          <a:p xmlns:a="http://schemas.openxmlformats.org/drawingml/2006/main">
+            <a:r>
               <a:t>Nguồn: docs/TV1_Huong_Dan_Thuyet_Trinh.md, phân công docs/Ke_hoach_phan_cong_Project_DBMS_Nhom06.md. Mốc nói: 00:00–02:00.</a:t>
             </a:r>
           </a:p>
@@ -1206,12 +1216,22 @@
           <a:lstStyle xmlns:a="http://schemas.openxmlformats.org/drawingml/2006/main"/>
           <a:p xmlns:a="http://schemas.openxmlformats.org/drawingml/2006/main">
             <a:r>
-              <a:t>sp_GhiNhanChamCong thực hiện kiểm tra/ghi từng dòng. Java DAO mở một transaction trên cùng connection cho toàn batch, lỗi một dòng rollback batch. Không tuyên bố SP có TRY/CATCH riêng nếu source không có. SQL log TV2 21 PASS/0 FAIL là kiểm SQL, không tự chứng minh GUI batch. fn_TongPhuCap thuộc TV2 theo phân công, nằm module03; payroll đọc function này. Dynamic SQL đọc các function nằm caller TV4.</a:t>
-            </a:r>
-          </a:p>
-          <a:p xmlns:a="http://schemas.openxmlformats.org/drawingml/2006/main">
-            <a:r>
-              <a:t>Nguồn: docs/TV2_Huong_Dan_Thuyet_Trinh.md, phân công docs/Ke_hoach_phan_cong_Project_DBMS_Nhom06.md. Mốc nói: 02:00–04:00.</a:t>
+              <a:t>sp_GhiNhanChamCong bao bọc validation, INSERT và gán SCOPE_IDENTITY trong TRY...CATCH; bare THROW chuyển lỗi nguyên trạng về caller. SP không mở transaction riêng. ChamCongService dùng cùng JDBC connection cho cả batch và rollback toàn lô nếu một dòng lỗi.</a:t>
+            </a:r>
+          </a:p>
+          <a:p xmlns:a="http://schemas.openxmlformats.org/drawingml/2006/main">
+            <a:r>
+              <a:t>QA Option B cuối ngày 16/10/2026: 55 nguồn biên dịch với --release 11; controlled suite 179/179, SQL 21/21, concurrency 4/4 và JDBC 105 assertions PASS. Kiểm endpoint gồm SQLCMD/JDBC mismatch qua main Java thật, từ chối trước khi tạo database và không ghi fixture. Đây là QA SQL/JDBC, không thay thế kiểm GUI trực tiếp hoặc rehearsal.</a:t>
+            </a:r>
+          </a:p>
+          <a:p xmlns:a="http://schemas.openxmlformats.org/drawingml/2006/main">
+            <a:r>
+              <a:t>Bằng chứng mới: ../evidence/TV2/optionb-20261016/codex_final_report.md và thư mục run 20261016_003726_1ade8e9e. fn_TongPhuCap thuộc TV2, nằm module03; payroll đọc function này. Dynamic SQL đọc function thuộc caller TV4.</a:t>
+            </a:r>
+          </a:p>
+          <a:p xmlns:a="http://schemas.openxmlformats.org/drawingml/2006/main">
+            <a:r>
+              <a:t>Nguồn: docs/TV2_Huong_Dan_Thuyet_Trinh.md, docs/TV2_TASKLIST_HOAN_THIEN_20261015.md. Mốc nói: 02:00–04:00.</a:t>
             </a:r>
           </a:p>
         </p:txBody>
@@ -1729,6 +1749,7 @@
                 <a:spcPts val="0"/>
               </a:spcAft>
               <a:buNone/>
+              <a:defRPr/>
             </a:lvl1pPr>
             <a:lvl2pPr marL="0" indent="0">
               <a:lnSpc>
@@ -1741,6 +1762,7 @@
                 <a:spcPts val="0"/>
               </a:spcAft>
               <a:buNone/>
+              <a:defRPr/>
             </a:lvl2pPr>
             <a:lvl3pPr marL="0" indent="0">
               <a:lnSpc>
@@ -1753,6 +1775,7 @@
                 <a:spcPts val="0"/>
               </a:spcAft>
               <a:buNone/>
+              <a:defRPr/>
             </a:lvl3pPr>
             <a:lvl4pPr marL="0" indent="0">
               <a:lnSpc>
@@ -1765,6 +1788,7 @@
                 <a:spcPts val="0"/>
               </a:spcAft>
               <a:buNone/>
+              <a:defRPr/>
             </a:lvl4pPr>
             <a:lvl5pPr marL="0" indent="0">
               <a:lnSpc>
@@ -1777,6 +1801,7 @@
                 <a:spcPts val="0"/>
               </a:spcAft>
               <a:buNone/>
+              <a:defRPr/>
             </a:lvl5pPr>
             <a:lvl6pPr marL="0" indent="0">
               <a:lnSpc>
@@ -1789,6 +1814,7 @@
                 <a:spcPts val="0"/>
               </a:spcAft>
               <a:buNone/>
+              <a:defRPr/>
             </a:lvl6pPr>
             <a:lvl7pPr marL="0" indent="0">
               <a:lnSpc>
@@ -1801,6 +1827,7 @@
                 <a:spcPts val="0"/>
               </a:spcAft>
               <a:buNone/>
+              <a:defRPr/>
             </a:lvl7pPr>
             <a:lvl8pPr marL="0" indent="0">
               <a:lnSpc>
@@ -1813,6 +1840,7 @@
                 <a:spcPts val="0"/>
               </a:spcAft>
               <a:buNone/>
+              <a:defRPr/>
             </a:lvl8pPr>
             <a:lvl9pPr marL="0" indent="0">
               <a:lnSpc>
@@ -1825,6 +1853,7 @@
                 <a:spcPts val="0"/>
               </a:spcAft>
               <a:buNone/>
+              <a:defRPr/>
             </a:lvl9pPr>
           </a:lstStyle>
           <a:p xmlns:a="http://schemas.openxmlformats.org/drawingml/2006/main"/>
@@ -1886,6 +1915,7 @@
                 <a:spcPts val="0"/>
               </a:spcAft>
               <a:buNone/>
+              <a:defRPr/>
             </a:lvl1pPr>
             <a:lvl2pPr marL="0" indent="0">
               <a:lnSpc>
@@ -1898,6 +1928,7 @@
                 <a:spcPts val="0"/>
               </a:spcAft>
               <a:buNone/>
+              <a:defRPr/>
             </a:lvl2pPr>
             <a:lvl3pPr marL="0" indent="0">
               <a:lnSpc>
@@ -1910,6 +1941,7 @@
                 <a:spcPts val="0"/>
               </a:spcAft>
               <a:buNone/>
+              <a:defRPr/>
             </a:lvl3pPr>
             <a:lvl4pPr marL="0" indent="0">
               <a:lnSpc>
@@ -1922,6 +1954,7 @@
                 <a:spcPts val="0"/>
               </a:spcAft>
               <a:buNone/>
+              <a:defRPr/>
             </a:lvl4pPr>
             <a:lvl5pPr marL="0" indent="0">
               <a:lnSpc>
@@ -1934,6 +1967,7 @@
                 <a:spcPts val="0"/>
               </a:spcAft>
               <a:buNone/>
+              <a:defRPr/>
             </a:lvl5pPr>
             <a:lvl6pPr marL="0" indent="0">
               <a:lnSpc>
@@ -1946,6 +1980,7 @@
                 <a:spcPts val="0"/>
               </a:spcAft>
               <a:buNone/>
+              <a:defRPr/>
             </a:lvl6pPr>
             <a:lvl7pPr marL="0" indent="0">
               <a:lnSpc>
@@ -1958,6 +1993,7 @@
                 <a:spcPts val="0"/>
               </a:spcAft>
               <a:buNone/>
+              <a:defRPr/>
             </a:lvl7pPr>
             <a:lvl8pPr marL="0" indent="0">
               <a:lnSpc>
@@ -1970,6 +2006,7 @@
                 <a:spcPts val="0"/>
               </a:spcAft>
               <a:buNone/>
+              <a:defRPr/>
             </a:lvl8pPr>
             <a:lvl9pPr marL="0" indent="0">
               <a:lnSpc>
@@ -1982,6 +2019,7 @@
                 <a:spcPts val="0"/>
               </a:spcAft>
               <a:buNone/>
+              <a:defRPr/>
             </a:lvl9pPr>
           </a:lstStyle>
           <a:p xmlns:a="http://schemas.openxmlformats.org/drawingml/2006/main"/>
@@ -2060,6 +2098,7 @@
                 <a:spcPts val="0"/>
               </a:spcAft>
               <a:buNone/>
+              <a:defRPr/>
             </a:lvl1pPr>
             <a:lvl2pPr marL="0" indent="0">
               <a:lnSpc>
@@ -2072,6 +2111,7 @@
                 <a:spcPts val="0"/>
               </a:spcAft>
               <a:buNone/>
+              <a:defRPr/>
             </a:lvl2pPr>
             <a:lvl3pPr marL="0" indent="0">
               <a:lnSpc>
@@ -2084,6 +2124,7 @@
                 <a:spcPts val="0"/>
               </a:spcAft>
               <a:buNone/>
+              <a:defRPr/>
             </a:lvl3pPr>
             <a:lvl4pPr marL="0" indent="0">
               <a:lnSpc>
@@ -2096,6 +2137,7 @@
                 <a:spcPts val="0"/>
               </a:spcAft>
               <a:buNone/>
+              <a:defRPr/>
             </a:lvl4pPr>
             <a:lvl5pPr marL="0" indent="0">
               <a:lnSpc>
@@ -2108,6 +2150,7 @@
                 <a:spcPts val="0"/>
               </a:spcAft>
               <a:buNone/>
+              <a:defRPr/>
             </a:lvl5pPr>
             <a:lvl6pPr marL="0" indent="0">
               <a:lnSpc>
@@ -2120,6 +2163,7 @@
                 <a:spcPts val="0"/>
               </a:spcAft>
               <a:buNone/>
+              <a:defRPr/>
             </a:lvl6pPr>
             <a:lvl7pPr marL="0" indent="0">
               <a:lnSpc>
@@ -2132,6 +2176,7 @@
                 <a:spcPts val="0"/>
               </a:spcAft>
               <a:buNone/>
+              <a:defRPr/>
             </a:lvl7pPr>
             <a:lvl8pPr marL="0" indent="0">
               <a:lnSpc>
@@ -2144,6 +2189,7 @@
                 <a:spcPts val="0"/>
               </a:spcAft>
               <a:buNone/>
+              <a:defRPr/>
             </a:lvl8pPr>
             <a:lvl9pPr marL="0" indent="0">
               <a:lnSpc>
@@ -2156,6 +2202,7 @@
                 <a:spcPts val="0"/>
               </a:spcAft>
               <a:buNone/>
+              <a:defRPr/>
             </a:lvl9pPr>
           </a:lstStyle>
           <a:p xmlns:a="http://schemas.openxmlformats.org/drawingml/2006/main"/>
@@ -2234,6 +2281,7 @@
                 <a:spcPts val="0"/>
               </a:spcAft>
               <a:buNone/>
+              <a:defRPr/>
             </a:lvl1pPr>
             <a:lvl2pPr marL="0" indent="0">
               <a:lnSpc>
@@ -2246,6 +2294,7 @@
                 <a:spcPts val="0"/>
               </a:spcAft>
               <a:buNone/>
+              <a:defRPr/>
             </a:lvl2pPr>
             <a:lvl3pPr marL="0" indent="0">
               <a:lnSpc>
@@ -2258,6 +2307,7 @@
                 <a:spcPts val="0"/>
               </a:spcAft>
               <a:buNone/>
+              <a:defRPr/>
             </a:lvl3pPr>
             <a:lvl4pPr marL="0" indent="0">
               <a:lnSpc>
@@ -2270,6 +2320,7 @@
                 <a:spcPts val="0"/>
               </a:spcAft>
               <a:buNone/>
+              <a:defRPr/>
             </a:lvl4pPr>
             <a:lvl5pPr marL="0" indent="0">
               <a:lnSpc>
@@ -2282,6 +2333,7 @@
                 <a:spcPts val="0"/>
               </a:spcAft>
               <a:buNone/>
+              <a:defRPr/>
             </a:lvl5pPr>
             <a:lvl6pPr marL="0" indent="0">
               <a:lnSpc>
@@ -2294,6 +2346,7 @@
                 <a:spcPts val="0"/>
               </a:spcAft>
               <a:buNone/>
+              <a:defRPr/>
             </a:lvl6pPr>
             <a:lvl7pPr marL="0" indent="0">
               <a:lnSpc>
@@ -2306,6 +2359,7 @@
                 <a:spcPts val="0"/>
               </a:spcAft>
               <a:buNone/>
+              <a:defRPr/>
             </a:lvl7pPr>
             <a:lvl8pPr marL="0" indent="0">
               <a:lnSpc>
@@ -2318,6 +2372,7 @@
                 <a:spcPts val="0"/>
               </a:spcAft>
               <a:buNone/>
+              <a:defRPr/>
             </a:lvl8pPr>
             <a:lvl9pPr marL="0" indent="0">
               <a:lnSpc>
@@ -2330,6 +2385,7 @@
                 <a:spcPts val="0"/>
               </a:spcAft>
               <a:buNone/>
+              <a:defRPr/>
             </a:lvl9pPr>
           </a:lstStyle>
           <a:p xmlns:a="http://schemas.openxmlformats.org/drawingml/2006/main"/>
@@ -2391,6 +2447,7 @@
                 <a:spcPts val="1200"/>
               </a:spcAft>
               <a:buChar char="•"/>
+              <a:defRPr/>
             </a:lvl1pPr>
             <a:lvl2pPr marL="533400" indent="-228600">
               <a:lnSpc>
@@ -2403,6 +2460,7 @@
                 <a:spcPts val="1200"/>
               </a:spcAft>
               <a:buChar char="•"/>
+              <a:defRPr/>
             </a:lvl2pPr>
             <a:lvl3pPr marL="838200" indent="-228600">
               <a:lnSpc>
@@ -2415,6 +2473,7 @@
                 <a:spcPts val="1200"/>
               </a:spcAft>
               <a:buChar char="•"/>
+              <a:defRPr/>
             </a:lvl3pPr>
             <a:lvl4pPr marL="1143000" indent="-228600">
               <a:lnSpc>
@@ -2427,6 +2486,7 @@
                 <a:spcPts val="1200"/>
               </a:spcAft>
               <a:buChar char="•"/>
+              <a:defRPr/>
             </a:lvl4pPr>
             <a:lvl5pPr marL="1447800" indent="-228600">
               <a:lnSpc>
@@ -2439,6 +2499,7 @@
                 <a:spcPts val="1200"/>
               </a:spcAft>
               <a:buChar char="•"/>
+              <a:defRPr/>
             </a:lvl5pPr>
             <a:lvl6pPr marL="1752600" indent="-228600">
               <a:lnSpc>
@@ -2451,6 +2512,7 @@
                 <a:spcPts val="1200"/>
               </a:spcAft>
               <a:buChar char="•"/>
+              <a:defRPr/>
             </a:lvl6pPr>
             <a:lvl7pPr marL="2057400" indent="-228600">
               <a:lnSpc>
@@ -2463,6 +2525,7 @@
                 <a:spcPts val="1200"/>
               </a:spcAft>
               <a:buChar char="•"/>
+              <a:defRPr/>
             </a:lvl7pPr>
             <a:lvl8pPr marL="2362200" indent="-228600">
               <a:lnSpc>
@@ -2475,6 +2538,7 @@
                 <a:spcPts val="1200"/>
               </a:spcAft>
               <a:buChar char="•"/>
+              <a:defRPr/>
             </a:lvl8pPr>
             <a:lvl9pPr marL="2667000" indent="-228600">
               <a:lnSpc>
@@ -2487,6 +2551,7 @@
                 <a:spcPts val="1200"/>
               </a:spcAft>
               <a:buChar char="•"/>
+              <a:defRPr/>
             </a:lvl9pPr>
           </a:lstStyle>
           <a:p xmlns:a="http://schemas.openxmlformats.org/drawingml/2006/main"/>
@@ -2565,6 +2630,7 @@
                 <a:spcPts val="0"/>
               </a:spcAft>
               <a:buNone/>
+              <a:defRPr/>
             </a:lvl1pPr>
             <a:lvl2pPr marL="0" indent="0">
               <a:lnSpc>
@@ -2577,6 +2643,7 @@
                 <a:spcPts val="0"/>
               </a:spcAft>
               <a:buNone/>
+              <a:defRPr/>
             </a:lvl2pPr>
             <a:lvl3pPr marL="0" indent="0">
               <a:lnSpc>
@@ -2589,6 +2656,7 @@
                 <a:spcPts val="0"/>
               </a:spcAft>
               <a:buNone/>
+              <a:defRPr/>
             </a:lvl3pPr>
             <a:lvl4pPr marL="0" indent="0">
               <a:lnSpc>
@@ -2601,6 +2669,7 @@
                 <a:spcPts val="0"/>
               </a:spcAft>
               <a:buNone/>
+              <a:defRPr/>
             </a:lvl4pPr>
             <a:lvl5pPr marL="0" indent="0">
               <a:lnSpc>
@@ -2613,6 +2682,7 @@
                 <a:spcPts val="0"/>
               </a:spcAft>
               <a:buNone/>
+              <a:defRPr/>
             </a:lvl5pPr>
             <a:lvl6pPr marL="0" indent="0">
               <a:lnSpc>
@@ -2625,6 +2695,7 @@
                 <a:spcPts val="0"/>
               </a:spcAft>
               <a:buNone/>
+              <a:defRPr/>
             </a:lvl6pPr>
             <a:lvl7pPr marL="0" indent="0">
               <a:lnSpc>
@@ -2637,6 +2708,7 @@
                 <a:spcPts val="0"/>
               </a:spcAft>
               <a:buNone/>
+              <a:defRPr/>
             </a:lvl7pPr>
             <a:lvl8pPr marL="0" indent="0">
               <a:lnSpc>
@@ -2649,6 +2721,7 @@
                 <a:spcPts val="0"/>
               </a:spcAft>
               <a:buNone/>
+              <a:defRPr/>
             </a:lvl8pPr>
             <a:lvl9pPr marL="0" indent="0">
               <a:lnSpc>
@@ -2661,6 +2734,7 @@
                 <a:spcPts val="0"/>
               </a:spcAft>
               <a:buNone/>
+              <a:defRPr/>
             </a:lvl9pPr>
           </a:lstStyle>
           <a:p xmlns:a="http://schemas.openxmlformats.org/drawingml/2006/main"/>
@@ -2722,6 +2796,7 @@
                 <a:spcPts val="1200"/>
               </a:spcAft>
               <a:buChar char="•"/>
+              <a:defRPr/>
             </a:lvl1pPr>
             <a:lvl2pPr marL="533400" indent="-228600">
               <a:lnSpc>
@@ -2734,6 +2809,7 @@
                 <a:spcPts val="1200"/>
               </a:spcAft>
               <a:buChar char="•"/>
+              <a:defRPr/>
             </a:lvl2pPr>
             <a:lvl3pPr marL="838200" indent="-228600">
               <a:lnSpc>
@@ -2746,6 +2822,7 @@
                 <a:spcPts val="1200"/>
               </a:spcAft>
               <a:buChar char="•"/>
+              <a:defRPr/>
             </a:lvl3pPr>
             <a:lvl4pPr marL="1143000" indent="-228600">
               <a:lnSpc>
@@ -2758,6 +2835,7 @@
                 <a:spcPts val="1200"/>
               </a:spcAft>
               <a:buChar char="•"/>
+              <a:defRPr/>
             </a:lvl4pPr>
             <a:lvl5pPr marL="1447800" indent="-228600">
               <a:lnSpc>
@@ -2770,6 +2848,7 @@
                 <a:spcPts val="1200"/>
               </a:spcAft>
               <a:buChar char="•"/>
+              <a:defRPr/>
             </a:lvl5pPr>
             <a:lvl6pPr marL="1752600" indent="-228600">
               <a:lnSpc>
@@ -2782,6 +2861,7 @@
                 <a:spcPts val="1200"/>
               </a:spcAft>
               <a:buChar char="•"/>
+              <a:defRPr/>
             </a:lvl6pPr>
             <a:lvl7pPr marL="2057400" indent="-228600">
               <a:lnSpc>
@@ -2794,6 +2874,7 @@
                 <a:spcPts val="1200"/>
               </a:spcAft>
               <a:buChar char="•"/>
+              <a:defRPr/>
             </a:lvl7pPr>
             <a:lvl8pPr marL="2362200" indent="-228600">
               <a:lnSpc>
@@ -2806,6 +2887,7 @@
                 <a:spcPts val="1200"/>
               </a:spcAft>
               <a:buChar char="•"/>
+              <a:defRPr/>
             </a:lvl8pPr>
             <a:lvl9pPr marL="2667000" indent="-228600">
               <a:lnSpc>
@@ -2818,6 +2900,7 @@
                 <a:spcPts val="1200"/>
               </a:spcAft>
               <a:buChar char="•"/>
+              <a:defRPr/>
             </a:lvl9pPr>
           </a:lstStyle>
           <a:p xmlns:a="http://schemas.openxmlformats.org/drawingml/2006/main"/>
@@ -2879,6 +2962,7 @@
                 <a:spcPts val="1200"/>
               </a:spcAft>
               <a:buChar char="•"/>
+              <a:defRPr/>
             </a:lvl1pPr>
             <a:lvl2pPr marL="533400" indent="-228600">
               <a:lnSpc>
@@ -2891,6 +2975,7 @@
                 <a:spcPts val="1200"/>
               </a:spcAft>
               <a:buChar char="•"/>
+              <a:defRPr/>
             </a:lvl2pPr>
             <a:lvl3pPr marL="838200" indent="-228600">
               <a:lnSpc>
@@ -2903,6 +2988,7 @@
                 <a:spcPts val="1200"/>
               </a:spcAft>
               <a:buChar char="•"/>
+              <a:defRPr/>
             </a:lvl3pPr>
             <a:lvl4pPr marL="1143000" indent="-228600">
               <a:lnSpc>
@@ -2915,6 +3001,7 @@
                 <a:spcPts val="1200"/>
               </a:spcAft>
               <a:buChar char="•"/>
+              <a:defRPr/>
             </a:lvl4pPr>
             <a:lvl5pPr marL="1447800" indent="-228600">
               <a:lnSpc>
@@ -2927,6 +3014,7 @@
                 <a:spcPts val="1200"/>
               </a:spcAft>
               <a:buChar char="•"/>
+              <a:defRPr/>
             </a:lvl5pPr>
             <a:lvl6pPr marL="1752600" indent="-228600">
               <a:lnSpc>
@@ -2939,6 +3027,7 @@
                 <a:spcPts val="1200"/>
               </a:spcAft>
               <a:buChar char="•"/>
+              <a:defRPr/>
             </a:lvl6pPr>
             <a:lvl7pPr marL="2057400" indent="-228600">
               <a:lnSpc>
@@ -2951,6 +3040,7 @@
                 <a:spcPts val="1200"/>
               </a:spcAft>
               <a:buChar char="•"/>
+              <a:defRPr/>
             </a:lvl7pPr>
             <a:lvl8pPr marL="2362200" indent="-228600">
               <a:lnSpc>
@@ -2963,6 +3053,7 @@
                 <a:spcPts val="1200"/>
               </a:spcAft>
               <a:buChar char="•"/>
+              <a:defRPr/>
             </a:lvl8pPr>
             <a:lvl9pPr marL="2667000" indent="-228600">
               <a:lnSpc>
@@ -2975,6 +3066,7 @@
                 <a:spcPts val="1200"/>
               </a:spcAft>
               <a:buChar char="•"/>
+              <a:defRPr/>
             </a:lvl9pPr>
           </a:lstStyle>
           <a:p xmlns:a="http://schemas.openxmlformats.org/drawingml/2006/main"/>
@@ -3053,6 +3145,7 @@
                 <a:spcPts val="0"/>
               </a:spcAft>
               <a:buNone/>
+              <a:defRPr/>
             </a:lvl1pPr>
             <a:lvl2pPr marL="0" indent="0">
               <a:lnSpc>
@@ -3065,6 +3158,7 @@
                 <a:spcPts val="0"/>
               </a:spcAft>
               <a:buNone/>
+              <a:defRPr/>
             </a:lvl2pPr>
             <a:lvl3pPr marL="0" indent="0">
               <a:lnSpc>
@@ -3077,6 +3171,7 @@
                 <a:spcPts val="0"/>
               </a:spcAft>
               <a:buNone/>
+              <a:defRPr/>
             </a:lvl3pPr>
             <a:lvl4pPr marL="0" indent="0">
               <a:lnSpc>
@@ -3089,6 +3184,7 @@
                 <a:spcPts val="0"/>
               </a:spcAft>
               <a:buNone/>
+              <a:defRPr/>
             </a:lvl4pPr>
             <a:lvl5pPr marL="0" indent="0">
               <a:lnSpc>
@@ -3101,6 +3197,7 @@
                 <a:spcPts val="0"/>
               </a:spcAft>
               <a:buNone/>
+              <a:defRPr/>
             </a:lvl5pPr>
             <a:lvl6pPr marL="0" indent="0">
               <a:lnSpc>
@@ -3113,6 +3210,7 @@
                 <a:spcPts val="0"/>
               </a:spcAft>
               <a:buNone/>
+              <a:defRPr/>
             </a:lvl6pPr>
             <a:lvl7pPr marL="0" indent="0">
               <a:lnSpc>
@@ -3125,6 +3223,7 @@
                 <a:spcPts val="0"/>
               </a:spcAft>
               <a:buNone/>
+              <a:defRPr/>
             </a:lvl7pPr>
             <a:lvl8pPr marL="0" indent="0">
               <a:lnSpc>
@@ -3137,6 +3236,7 @@
                 <a:spcPts val="0"/>
               </a:spcAft>
               <a:buNone/>
+              <a:defRPr/>
             </a:lvl8pPr>
             <a:lvl9pPr marL="0" indent="0">
               <a:lnSpc>
@@ -3149,6 +3249,7 @@
                 <a:spcPts val="0"/>
               </a:spcAft>
               <a:buNone/>
+              <a:defRPr/>
             </a:lvl9pPr>
           </a:lstStyle>
           <a:p xmlns:a="http://schemas.openxmlformats.org/drawingml/2006/main"/>
@@ -3210,6 +3311,7 @@
                 <a:spcPts val="1200"/>
               </a:spcAft>
               <a:buChar char="•"/>
+              <a:defRPr/>
             </a:lvl1pPr>
             <a:lvl2pPr marL="533400" indent="-228600">
               <a:lnSpc>
@@ -3222,6 +3324,7 @@
                 <a:spcPts val="1200"/>
               </a:spcAft>
               <a:buChar char="•"/>
+              <a:defRPr/>
             </a:lvl2pPr>
             <a:lvl3pPr marL="838200" indent="-228600">
               <a:lnSpc>
@@ -3234,6 +3337,7 @@
                 <a:spcPts val="1200"/>
               </a:spcAft>
               <a:buChar char="•"/>
+              <a:defRPr/>
             </a:lvl3pPr>
             <a:lvl4pPr marL="1143000" indent="-228600">
               <a:lnSpc>
@@ -3246,6 +3350,7 @@
                 <a:spcPts val="1200"/>
               </a:spcAft>
               <a:buChar char="•"/>
+              <a:defRPr/>
             </a:lvl4pPr>
             <a:lvl5pPr marL="1447800" indent="-228600">
               <a:lnSpc>
@@ -3258,6 +3363,7 @@
                 <a:spcPts val="1200"/>
               </a:spcAft>
               <a:buChar char="•"/>
+              <a:defRPr/>
             </a:lvl5pPr>
             <a:lvl6pPr marL="1752600" indent="-228600">
               <a:lnSpc>
@@ -3270,6 +3376,7 @@
                 <a:spcPts val="1200"/>
               </a:spcAft>
               <a:buChar char="•"/>
+              <a:defRPr/>
             </a:lvl6pPr>
             <a:lvl7pPr marL="2057400" indent="-228600">
               <a:lnSpc>
@@ -3282,6 +3389,7 @@
                 <a:spcPts val="1200"/>
               </a:spcAft>
               <a:buChar char="•"/>
+              <a:defRPr/>
             </a:lvl7pPr>
             <a:lvl8pPr marL="2362200" indent="-228600">
               <a:lnSpc>
@@ -3294,6 +3402,7 @@
                 <a:spcPts val="1200"/>
               </a:spcAft>
               <a:buChar char="•"/>
+              <a:defRPr/>
             </a:lvl8pPr>
             <a:lvl9pPr marL="2667000" indent="-228600">
               <a:lnSpc>
@@ -3306,6 +3415,7 @@
                 <a:spcPts val="1200"/>
               </a:spcAft>
               <a:buChar char="•"/>
+              <a:defRPr/>
             </a:lvl9pPr>
           </a:lstStyle>
           <a:p xmlns:a="http://schemas.openxmlformats.org/drawingml/2006/main"/>
@@ -3354,12 +3464,12 @@
   </p:cSld>
   <p:clrMap bg1="lt1" tx1="dk1" bg2="lt2" tx2="dk2" accent1="accent1" accent2="accent2" accent3="accent3" accent4="accent4" accent5="accent5" accent6="accent6" hlink="hlink" folHlink="folHlink"/>
   <p:sldLayoutIdLst>
-    <p:sldLayoutId xmlns:r="http://schemas.openxmlformats.org/officeDocument/2006/relationships" id="2147483649" r:id="Ra096c6dce41045fe"/>
-    <p:sldLayoutId xmlns:r="http://schemas.openxmlformats.org/officeDocument/2006/relationships" id="2147483650" r:id="R976d816cacd54c09"/>
-    <p:sldLayoutId xmlns:r="http://schemas.openxmlformats.org/officeDocument/2006/relationships" id="2147483651" r:id="R5912c253b15f4744"/>
-    <p:sldLayoutId xmlns:r="http://schemas.openxmlformats.org/officeDocument/2006/relationships" id="2147483652" r:id="Rc5fbca7d63304d26"/>
-    <p:sldLayoutId xmlns:r="http://schemas.openxmlformats.org/officeDocument/2006/relationships" id="2147483653" r:id="Rb6d889e38e704ee8"/>
-    <p:sldLayoutId xmlns:r="http://schemas.openxmlformats.org/officeDocument/2006/relationships" id="2147483654" r:id="Rbf6ab10e82db4dc8"/>
+    <p:sldLayoutId xmlns:r="http://schemas.openxmlformats.org/officeDocument/2006/relationships" id="2147483649" r:id="Rb36a65d900124425"/>
+    <p:sldLayoutId xmlns:r="http://schemas.openxmlformats.org/officeDocument/2006/relationships" id="2147483650" r:id="R0599a3c332eb4d3e"/>
+    <p:sldLayoutId xmlns:r="http://schemas.openxmlformats.org/officeDocument/2006/relationships" id="2147483651" r:id="R8885423e1ef14b7c"/>
+    <p:sldLayoutId xmlns:r="http://schemas.openxmlformats.org/officeDocument/2006/relationships" id="2147483652" r:id="R96a7c2f6318742be"/>
+    <p:sldLayoutId xmlns:r="http://schemas.openxmlformats.org/officeDocument/2006/relationships" id="2147483653" r:id="Rf04eaa8ad7e94561"/>
+    <p:sldLayoutId xmlns:r="http://schemas.openxmlformats.org/officeDocument/2006/relationships" id="2147483654" r:id="Re147b9f730124546"/>
   </p:sldLayoutIdLst>
   <p:txStyles>
     <p:titleStyle>
@@ -3948,6 +4058,7 @@
           </a:lstStyle>
           <a:p xmlns:a="http://schemas.openxmlformats.org/drawingml/2006/main">
             <a:pPr>
+              <a:buNone/>
               <a:defRPr sz="2850" b="1">
                 <a:solidFill>
                   <a:srgbClr val="17243B"/>
@@ -4014,6 +4125,7 @@
           </a:lstStyle>
           <a:p xmlns:a="http://schemas.openxmlformats.org/drawingml/2006/main">
             <a:pPr>
+              <a:buNone/>
               <a:defRPr sz="1350" b="0">
                 <a:solidFill>
                   <a:srgbClr val="52627A"/>
@@ -4080,6 +4192,7 @@
           </a:lstStyle>
           <a:p xmlns:a="http://schemas.openxmlformats.org/drawingml/2006/main">
             <a:pPr>
+              <a:buNone/>
               <a:defRPr sz="2100" b="1">
                 <a:solidFill>
                   <a:srgbClr val="4F46E5"/>
@@ -4146,6 +4259,7 @@
           </a:lstStyle>
           <a:p xmlns:a="http://schemas.openxmlformats.org/drawingml/2006/main">
             <a:pPr>
+              <a:buNone/>
               <a:defRPr sz="2400" b="1">
                 <a:solidFill>
                   <a:srgbClr val="4F46E5"/>
@@ -4212,6 +4326,7 @@
           </a:lstStyle>
           <a:p xmlns:a="http://schemas.openxmlformats.org/drawingml/2006/main">
             <a:pPr>
+              <a:buNone/>
               <a:defRPr sz="2550" b="0">
                 <a:solidFill>
                   <a:srgbClr val="17243B"/>
@@ -4235,6 +4350,7 @@
           </a:p>
           <a:p xmlns:a="http://schemas.openxmlformats.org/drawingml/2006/main">
             <a:pPr>
+              <a:buNone/>
               <a:defRPr sz="2550" b="0">
                 <a:solidFill>
                   <a:srgbClr val="17243B"/>
@@ -4258,6 +4374,7 @@
           </a:p>
           <a:p xmlns:a="http://schemas.openxmlformats.org/drawingml/2006/main">
             <a:pPr>
+              <a:buNone/>
               <a:defRPr sz="2550" b="0">
                 <a:solidFill>
                   <a:srgbClr val="17243B"/>
@@ -4324,6 +4441,7 @@
           </a:lstStyle>
           <a:p xmlns:a="http://schemas.openxmlformats.org/drawingml/2006/main">
             <a:pPr>
+              <a:buNone/>
               <a:defRPr sz="2550" b="1">
                 <a:solidFill>
                   <a:srgbClr val="4F46E5"/>
@@ -4390,6 +4508,7 @@
           </a:lstStyle>
           <a:p xmlns:a="http://schemas.openxmlformats.org/drawingml/2006/main">
             <a:pPr>
+              <a:buNone/>
               <a:defRPr sz="2100" b="0">
                 <a:solidFill>
                   <a:srgbClr val="17243B"/>
@@ -4485,6 +4604,7 @@
           </a:lstStyle>
           <a:p xmlns:a="http://schemas.openxmlformats.org/drawingml/2006/main">
             <a:pPr>
+              <a:buNone/>
               <a:defRPr sz="2850" b="1">
                 <a:solidFill>
                   <a:srgbClr val="17243B"/>
@@ -4551,6 +4671,7 @@
           </a:lstStyle>
           <a:p xmlns:a="http://schemas.openxmlformats.org/drawingml/2006/main">
             <a:pPr>
+              <a:buNone/>
               <a:defRPr sz="1350" b="0">
                 <a:solidFill>
                   <a:srgbClr val="52627A"/>
@@ -4617,6 +4738,7 @@
           </a:lstStyle>
           <a:p xmlns:a="http://schemas.openxmlformats.org/drawingml/2006/main">
             <a:pPr>
+              <a:buNone/>
               <a:defRPr sz="2100" b="1">
                 <a:solidFill>
                   <a:srgbClr val="4F46E5"/>
@@ -4683,6 +4805,7 @@
           </a:lstStyle>
           <a:p xmlns:a="http://schemas.openxmlformats.org/drawingml/2006/main">
             <a:pPr>
+              <a:buNone/>
               <a:defRPr sz="2250" b="1">
                 <a:solidFill>
                   <a:srgbClr val="4F46E5"/>
@@ -4749,6 +4872,7 @@
           </a:lstStyle>
           <a:p xmlns:a="http://schemas.openxmlformats.org/drawingml/2006/main">
             <a:pPr>
+              <a:buNone/>
               <a:defRPr sz="2250" b="0">
                 <a:solidFill>
                   <a:srgbClr val="17243B"/>
@@ -4777,7 +4901,7 @@
           <p:cNvPr id="6" name="">
             <a:extLst xmlns:a="http://schemas.openxmlformats.org/drawingml/2006/main">
               <a:ext uri="{FF2B5EF4-FFF2-40B4-BE49-F238E27FC236}">
-                <a16:creationId xmlns:a16="http://schemas.microsoft.com/office/drawing/2014/main" id="{45520A9A-ADDA-4415-ACDE-63B4C9AD31F6}"/>
+                <a16:creationId xmlns:a16="http://schemas.microsoft.com/office/drawing/2014/main" id="{310D5A1A-824F-4BAA-9380-E6A24776AF1B}"/>
               </a:ext>
             </a:extLst>
           </p:cNvPr>
@@ -5469,6 +5593,7 @@
           </a:lstStyle>
           <a:p xmlns:a="http://schemas.openxmlformats.org/drawingml/2006/main">
             <a:pPr>
+              <a:buNone/>
               <a:defRPr sz="2850" b="1">
                 <a:solidFill>
                   <a:srgbClr val="17243B"/>
@@ -5535,6 +5660,7 @@
           </a:lstStyle>
           <a:p xmlns:a="http://schemas.openxmlformats.org/drawingml/2006/main">
             <a:pPr>
+              <a:buNone/>
               <a:defRPr sz="1350" b="0">
                 <a:solidFill>
                   <a:srgbClr val="52627A"/>
@@ -5601,6 +5727,7 @@
           </a:lstStyle>
           <a:p xmlns:a="http://schemas.openxmlformats.org/drawingml/2006/main">
             <a:pPr>
+              <a:buNone/>
               <a:defRPr sz="2100" b="1">
                 <a:solidFill>
                   <a:srgbClr val="4F46E5"/>
@@ -5667,6 +5794,7 @@
           </a:lstStyle>
           <a:p xmlns:a="http://schemas.openxmlformats.org/drawingml/2006/main">
             <a:pPr>
+              <a:buNone/>
               <a:defRPr sz="2175" b="1">
                 <a:solidFill>
                   <a:srgbClr val="4F46E5"/>
@@ -5733,6 +5861,7 @@
           </a:lstStyle>
           <a:p xmlns:a="http://schemas.openxmlformats.org/drawingml/2006/main">
             <a:pPr>
+              <a:buNone/>
               <a:defRPr sz="2025" b="0">
                 <a:solidFill>
                   <a:srgbClr val="17243B"/>
@@ -5799,6 +5928,7 @@
           </a:lstStyle>
           <a:p xmlns:a="http://schemas.openxmlformats.org/drawingml/2006/main">
             <a:pPr>
+              <a:buNone/>
               <a:defRPr sz="2175" b="1">
                 <a:solidFill>
                   <a:srgbClr val="4F46E5"/>
@@ -5865,6 +5995,7 @@
           </a:lstStyle>
           <a:p xmlns:a="http://schemas.openxmlformats.org/drawingml/2006/main">
             <a:pPr>
+              <a:buNone/>
               <a:defRPr sz="2025" b="0">
                 <a:solidFill>
                   <a:srgbClr val="17243B"/>
@@ -5931,6 +6062,7 @@
           </a:lstStyle>
           <a:p xmlns:a="http://schemas.openxmlformats.org/drawingml/2006/main">
             <a:pPr>
+              <a:buNone/>
               <a:defRPr sz="2175" b="1">
                 <a:solidFill>
                   <a:srgbClr val="4F46E5"/>
@@ -5997,6 +6129,7 @@
           </a:lstStyle>
           <a:p xmlns:a="http://schemas.openxmlformats.org/drawingml/2006/main">
             <a:pPr>
+              <a:buNone/>
               <a:defRPr sz="2025" b="0">
                 <a:solidFill>
                   <a:srgbClr val="17243B"/>
@@ -6092,6 +6225,7 @@
           </a:lstStyle>
           <a:p xmlns:a="http://schemas.openxmlformats.org/drawingml/2006/main">
             <a:pPr>
+              <a:buNone/>
               <a:defRPr sz="2850" b="1">
                 <a:solidFill>
                   <a:srgbClr val="17243B"/>
@@ -6158,6 +6292,7 @@
           </a:lstStyle>
           <a:p xmlns:a="http://schemas.openxmlformats.org/drawingml/2006/main">
             <a:pPr>
+              <a:buNone/>
               <a:defRPr sz="1350" b="0">
                 <a:solidFill>
                   <a:srgbClr val="52627A"/>
@@ -6224,6 +6359,7 @@
           </a:lstStyle>
           <a:p xmlns:a="http://schemas.openxmlformats.org/drawingml/2006/main">
             <a:pPr>
+              <a:buNone/>
               <a:defRPr sz="2100" b="1">
                 <a:solidFill>
                   <a:srgbClr val="4F46E5"/>
@@ -6290,6 +6426,7 @@
           </a:lstStyle>
           <a:p xmlns:a="http://schemas.openxmlformats.org/drawingml/2006/main">
             <a:pPr>
+              <a:buNone/>
               <a:defRPr sz="2175" b="1">
                 <a:solidFill>
                   <a:srgbClr val="4F46E5"/>
@@ -6356,6 +6493,7 @@
           </a:lstStyle>
           <a:p xmlns:a="http://schemas.openxmlformats.org/drawingml/2006/main">
             <a:pPr>
+              <a:buNone/>
               <a:defRPr sz="2025" b="0">
                 <a:solidFill>
                   <a:srgbClr val="17243B"/>
@@ -6422,6 +6560,7 @@
           </a:lstStyle>
           <a:p xmlns:a="http://schemas.openxmlformats.org/drawingml/2006/main">
             <a:pPr>
+              <a:buNone/>
               <a:defRPr sz="2175" b="1">
                 <a:solidFill>
                   <a:srgbClr val="4F46E5"/>
@@ -6488,6 +6627,7 @@
           </a:lstStyle>
           <a:p xmlns:a="http://schemas.openxmlformats.org/drawingml/2006/main">
             <a:pPr>
+              <a:buNone/>
               <a:defRPr sz="2025" b="0">
                 <a:solidFill>
                   <a:srgbClr val="17243B"/>
@@ -6554,6 +6694,7 @@
           </a:lstStyle>
           <a:p xmlns:a="http://schemas.openxmlformats.org/drawingml/2006/main">
             <a:pPr>
+              <a:buNone/>
               <a:defRPr sz="2175" b="1">
                 <a:solidFill>
                   <a:srgbClr val="4F46E5"/>
@@ -6620,6 +6761,7 @@
           </a:lstStyle>
           <a:p xmlns:a="http://schemas.openxmlformats.org/drawingml/2006/main">
             <a:pPr>
+              <a:buNone/>
               <a:defRPr sz="2025" b="0">
                 <a:solidFill>
                   <a:srgbClr val="17243B"/>
@@ -6715,6 +6857,7 @@
           </a:lstStyle>
           <a:p xmlns:a="http://schemas.openxmlformats.org/drawingml/2006/main">
             <a:pPr>
+              <a:buNone/>
               <a:defRPr sz="2850" b="1">
                 <a:solidFill>
                   <a:srgbClr val="17243B"/>
@@ -6781,6 +6924,7 @@
           </a:lstStyle>
           <a:p xmlns:a="http://schemas.openxmlformats.org/drawingml/2006/main">
             <a:pPr>
+              <a:buNone/>
               <a:defRPr sz="1350" b="0">
                 <a:solidFill>
                   <a:srgbClr val="52627A"/>
@@ -6847,6 +6991,7 @@
           </a:lstStyle>
           <a:p xmlns:a="http://schemas.openxmlformats.org/drawingml/2006/main">
             <a:pPr>
+              <a:buNone/>
               <a:defRPr sz="2100" b="1">
                 <a:solidFill>
                   <a:srgbClr val="4F46E5"/>
@@ -6875,7 +7020,7 @@
           <p:cNvPr id="4" name="">
             <a:extLst xmlns:a="http://schemas.openxmlformats.org/drawingml/2006/main">
               <a:ext uri="{FF2B5EF4-FFF2-40B4-BE49-F238E27FC236}">
-                <a16:creationId xmlns:a16="http://schemas.microsoft.com/office/drawing/2014/main" id="{B5A085DF-BD51-41C6-814E-FFBC77B1BDFD}"/>
+                <a16:creationId xmlns:a16="http://schemas.microsoft.com/office/drawing/2014/main" id="{4A7FBD02-FA6F-4EBA-8271-3E8B2C461CA2}"/>
               </a:ext>
             </a:extLst>
           </p:cNvPr>
@@ -7353,6 +7498,7 @@
           </a:lstStyle>
           <a:p xmlns:a="http://schemas.openxmlformats.org/drawingml/2006/main">
             <a:pPr>
+              <a:buNone/>
               <a:defRPr sz="2025" b="0">
                 <a:solidFill>
                   <a:srgbClr val="4F46E5"/>
@@ -7448,6 +7594,7 @@
           </a:lstStyle>
           <a:p xmlns:a="http://schemas.openxmlformats.org/drawingml/2006/main">
             <a:pPr>
+              <a:buNone/>
               <a:defRPr sz="2850" b="1">
                 <a:solidFill>
                   <a:srgbClr val="17243B"/>
@@ -7514,6 +7661,7 @@
           </a:lstStyle>
           <a:p xmlns:a="http://schemas.openxmlformats.org/drawingml/2006/main">
             <a:pPr>
+              <a:buNone/>
               <a:defRPr sz="1350" b="0">
                 <a:solidFill>
                   <a:srgbClr val="52627A"/>
@@ -7580,6 +7728,7 @@
           </a:lstStyle>
           <a:p xmlns:a="http://schemas.openxmlformats.org/drawingml/2006/main">
             <a:pPr>
+              <a:buNone/>
               <a:defRPr sz="2100" b="1">
                 <a:solidFill>
                   <a:srgbClr val="4F46E5"/>
@@ -7646,6 +7795,7 @@
           </a:lstStyle>
           <a:p xmlns:a="http://schemas.openxmlformats.org/drawingml/2006/main">
             <a:pPr>
+              <a:buNone/>
               <a:defRPr sz="2175" b="1">
                 <a:solidFill>
                   <a:srgbClr val="4F46E5"/>
@@ -7712,6 +7862,7 @@
           </a:lstStyle>
           <a:p xmlns:a="http://schemas.openxmlformats.org/drawingml/2006/main">
             <a:pPr>
+              <a:buNone/>
               <a:defRPr sz="2025" b="0">
                 <a:solidFill>
                   <a:srgbClr val="17243B"/>
@@ -7778,6 +7929,7 @@
           </a:lstStyle>
           <a:p xmlns:a="http://schemas.openxmlformats.org/drawingml/2006/main">
             <a:pPr>
+              <a:buNone/>
               <a:defRPr sz="2175" b="1">
                 <a:solidFill>
                   <a:srgbClr val="4F46E5"/>
@@ -7844,6 +7996,7 @@
           </a:lstStyle>
           <a:p xmlns:a="http://schemas.openxmlformats.org/drawingml/2006/main">
             <a:pPr>
+              <a:buNone/>
               <a:defRPr sz="2025" b="0">
                 <a:solidFill>
                   <a:srgbClr val="17243B"/>
@@ -7910,6 +8063,7 @@
           </a:lstStyle>
           <a:p xmlns:a="http://schemas.openxmlformats.org/drawingml/2006/main">
             <a:pPr>
+              <a:buNone/>
               <a:defRPr sz="2175" b="1">
                 <a:solidFill>
                   <a:srgbClr val="4F46E5"/>
@@ -7976,6 +8130,7 @@
           </a:lstStyle>
           <a:p xmlns:a="http://schemas.openxmlformats.org/drawingml/2006/main">
             <a:pPr>
+              <a:buNone/>
               <a:defRPr sz="2025" b="0">
                 <a:solidFill>
                   <a:srgbClr val="17243B"/>
@@ -8071,6 +8226,7 @@
           </a:lstStyle>
           <a:p xmlns:a="http://schemas.openxmlformats.org/drawingml/2006/main">
             <a:pPr>
+              <a:buNone/>
               <a:defRPr sz="2850" b="1">
                 <a:solidFill>
                   <a:srgbClr val="17243B"/>
@@ -8137,6 +8293,7 @@
           </a:lstStyle>
           <a:p xmlns:a="http://schemas.openxmlformats.org/drawingml/2006/main">
             <a:pPr>
+              <a:buNone/>
               <a:defRPr sz="1350" b="0">
                 <a:solidFill>
                   <a:srgbClr val="52627A"/>
@@ -8203,6 +8360,7 @@
           </a:lstStyle>
           <a:p xmlns:a="http://schemas.openxmlformats.org/drawingml/2006/main">
             <a:pPr>
+              <a:buNone/>
               <a:defRPr sz="2100" b="1">
                 <a:solidFill>
                   <a:srgbClr val="4F46E5"/>
@@ -8231,7 +8389,7 @@
           <p:cNvPr id="4" name="">
             <a:extLst xmlns:a="http://schemas.openxmlformats.org/drawingml/2006/main">
               <a:ext uri="{FF2B5EF4-FFF2-40B4-BE49-F238E27FC236}">
-                <a16:creationId xmlns:a16="http://schemas.microsoft.com/office/drawing/2014/main" id="{2494197F-D439-4CDF-AF58-D0C811ED75DF}"/>
+                <a16:creationId xmlns:a16="http://schemas.microsoft.com/office/drawing/2014/main" id="{5A9D9C57-5401-472D-9579-8B2271DACF5D}"/>
               </a:ext>
             </a:extLst>
           </p:cNvPr>
@@ -8709,6 +8867,7 @@
           </a:lstStyle>
           <a:p xmlns:a="http://schemas.openxmlformats.org/drawingml/2006/main">
             <a:pPr>
+              <a:buNone/>
               <a:defRPr sz="1950" b="1">
                 <a:solidFill>
                   <a:srgbClr val="4F46E5"/>
@@ -8804,6 +8963,7 @@
           </a:lstStyle>
           <a:p xmlns:a="http://schemas.openxmlformats.org/drawingml/2006/main">
             <a:pPr>
+              <a:buNone/>
               <a:defRPr sz="2850" b="1">
                 <a:solidFill>
                   <a:srgbClr val="17243B"/>
@@ -8870,6 +9030,7 @@
           </a:lstStyle>
           <a:p xmlns:a="http://schemas.openxmlformats.org/drawingml/2006/main">
             <a:pPr>
+              <a:buNone/>
               <a:defRPr sz="1350" b="0">
                 <a:solidFill>
                   <a:srgbClr val="52627A"/>
@@ -8936,6 +9097,7 @@
           </a:lstStyle>
           <a:p xmlns:a="http://schemas.openxmlformats.org/drawingml/2006/main">
             <a:pPr>
+              <a:buNone/>
               <a:defRPr sz="2100" b="1">
                 <a:solidFill>
                   <a:srgbClr val="4F46E5"/>
@@ -8964,7 +9126,7 @@
           <p:cNvPr id="4" name="">
             <a:extLst xmlns:a="http://schemas.openxmlformats.org/drawingml/2006/main">
               <a:ext uri="{FF2B5EF4-FFF2-40B4-BE49-F238E27FC236}">
-                <a16:creationId xmlns:a16="http://schemas.microsoft.com/office/drawing/2014/main" id="{E2EFF7DE-7053-4E78-ABDA-1ABB777ECDAD}"/>
+                <a16:creationId xmlns:a16="http://schemas.microsoft.com/office/drawing/2014/main" id="{4121109F-D8E8-49B2-95FD-1621DAE9014B}"/>
               </a:ext>
             </a:extLst>
           </p:cNvPr>
@@ -8974,7 +9136,7 @@
           <p:nvPr/>
         </p:nvPicPr>
         <p:blipFill>
-          <a:blip xmlns:r="http://schemas.openxmlformats.org/officeDocument/2006/relationships" xmlns:a="http://schemas.openxmlformats.org/drawingml/2006/main" r:embed="Ra22b345160034b79"/>
+          <a:blip xmlns:r="http://schemas.openxmlformats.org/officeDocument/2006/relationships" xmlns:a="http://schemas.openxmlformats.org/drawingml/2006/main" r:embed="Rd0c46cdbab014086"/>
           <a:stretch xmlns:a="http://schemas.openxmlformats.org/drawingml/2006/main"/>
         </p:blipFill>
         <p:spPr>
@@ -9030,6 +9192,7 @@
           </a:lstStyle>
           <a:p xmlns:a="http://schemas.openxmlformats.org/drawingml/2006/main">
             <a:pPr>
+              <a:buNone/>
               <a:defRPr sz="2550" b="1">
                 <a:solidFill>
                   <a:srgbClr val="4F46E5"/>
@@ -9096,6 +9259,7 @@
           </a:lstStyle>
           <a:p xmlns:a="http://schemas.openxmlformats.org/drawingml/2006/main">
             <a:pPr>
+              <a:buNone/>
               <a:defRPr sz="1800" b="0">
                 <a:solidFill>
                   <a:srgbClr val="17243B"/>
@@ -9124,6 +9288,7 @@
           </a:p>
           <a:p xmlns:a="http://schemas.openxmlformats.org/drawingml/2006/main">
             <a:pPr>
+              <a:buNone/>
               <a:defRPr sz="1800" b="0">
                 <a:solidFill>
                   <a:srgbClr val="17243B"/>
@@ -9147,6 +9312,7 @@
           </a:p>
           <a:p xmlns:a="http://schemas.openxmlformats.org/drawingml/2006/main">
             <a:pPr>
+              <a:buNone/>
               <a:defRPr sz="1800" b="0">
                 <a:solidFill>
                   <a:srgbClr val="17243B"/>
@@ -9175,6 +9341,7 @@
           </a:p>
           <a:p xmlns:a="http://schemas.openxmlformats.org/drawingml/2006/main">
             <a:pPr>
+              <a:buNone/>
               <a:defRPr sz="1800" b="0">
                 <a:solidFill>
                   <a:srgbClr val="17243B"/>
@@ -9198,6 +9365,7 @@
           </a:p>
           <a:p xmlns:a="http://schemas.openxmlformats.org/drawingml/2006/main">
             <a:pPr>
+              <a:buNone/>
               <a:defRPr sz="1800" b="0">
                 <a:solidFill>
                   <a:srgbClr val="17243B"/>
@@ -9293,6 +9461,7 @@
           </a:lstStyle>
           <a:p xmlns:a="http://schemas.openxmlformats.org/drawingml/2006/main">
             <a:pPr>
+              <a:buNone/>
               <a:defRPr sz="2850" b="1">
                 <a:solidFill>
                   <a:srgbClr val="17243B"/>
@@ -9359,6 +9528,7 @@
           </a:lstStyle>
           <a:p xmlns:a="http://schemas.openxmlformats.org/drawingml/2006/main">
             <a:pPr>
+              <a:buNone/>
               <a:defRPr sz="1350" b="0">
                 <a:solidFill>
                   <a:srgbClr val="52627A"/>
@@ -9425,6 +9595,7 @@
           </a:lstStyle>
           <a:p xmlns:a="http://schemas.openxmlformats.org/drawingml/2006/main">
             <a:pPr>
+              <a:buNone/>
               <a:defRPr sz="2100" b="1">
                 <a:solidFill>
                   <a:srgbClr val="4F46E5"/>
@@ -9491,6 +9662,7 @@
           </a:lstStyle>
           <a:p xmlns:a="http://schemas.openxmlformats.org/drawingml/2006/main">
             <a:pPr>
+              <a:buNone/>
               <a:defRPr sz="2175" b="1">
                 <a:solidFill>
                   <a:srgbClr val="4F46E5"/>
@@ -9557,6 +9729,7 @@
           </a:lstStyle>
           <a:p xmlns:a="http://schemas.openxmlformats.org/drawingml/2006/main">
             <a:pPr>
+              <a:buNone/>
               <a:defRPr sz="2025" b="0">
                 <a:solidFill>
                   <a:srgbClr val="17243B"/>
@@ -9623,6 +9796,7 @@
           </a:lstStyle>
           <a:p xmlns:a="http://schemas.openxmlformats.org/drawingml/2006/main">
             <a:pPr>
+              <a:buNone/>
               <a:defRPr sz="2175" b="1">
                 <a:solidFill>
                   <a:srgbClr val="4F46E5"/>
@@ -9689,6 +9863,7 @@
           </a:lstStyle>
           <a:p xmlns:a="http://schemas.openxmlformats.org/drawingml/2006/main">
             <a:pPr>
+              <a:buNone/>
               <a:defRPr sz="2025" b="0">
                 <a:solidFill>
                   <a:srgbClr val="17243B"/>
@@ -9755,6 +9930,7 @@
           </a:lstStyle>
           <a:p xmlns:a="http://schemas.openxmlformats.org/drawingml/2006/main">
             <a:pPr>
+              <a:buNone/>
               <a:defRPr sz="2175" b="1">
                 <a:solidFill>
                   <a:srgbClr val="4F46E5"/>
@@ -9821,6 +9997,7 @@
           </a:lstStyle>
           <a:p xmlns:a="http://schemas.openxmlformats.org/drawingml/2006/main">
             <a:pPr>
+              <a:buNone/>
               <a:defRPr sz="2025" b="0">
                 <a:solidFill>
                   <a:srgbClr val="17243B"/>
@@ -9916,6 +10093,7 @@
           </a:lstStyle>
           <a:p xmlns:a="http://schemas.openxmlformats.org/drawingml/2006/main">
             <a:pPr>
+              <a:buNone/>
               <a:defRPr sz="2850" b="1">
                 <a:solidFill>
                   <a:srgbClr val="17243B"/>
@@ -9982,6 +10160,7 @@
           </a:lstStyle>
           <a:p xmlns:a="http://schemas.openxmlformats.org/drawingml/2006/main">
             <a:pPr>
+              <a:buNone/>
               <a:defRPr sz="1350" b="0">
                 <a:solidFill>
                   <a:srgbClr val="52627A"/>
@@ -10048,6 +10227,7 @@
           </a:lstStyle>
           <a:p xmlns:a="http://schemas.openxmlformats.org/drawingml/2006/main">
             <a:pPr>
+              <a:buNone/>
               <a:defRPr sz="2100" b="1">
                 <a:solidFill>
                   <a:srgbClr val="4F46E5"/>
@@ -10114,6 +10294,7 @@
           </a:lstStyle>
           <a:p xmlns:a="http://schemas.openxmlformats.org/drawingml/2006/main">
             <a:pPr>
+              <a:buNone/>
               <a:defRPr sz="2175" b="1">
                 <a:solidFill>
                   <a:srgbClr val="4F46E5"/>
@@ -10180,6 +10361,7 @@
           </a:lstStyle>
           <a:p xmlns:a="http://schemas.openxmlformats.org/drawingml/2006/main">
             <a:pPr>
+              <a:buNone/>
               <a:defRPr sz="2025" b="0">
                 <a:solidFill>
                   <a:srgbClr val="17243B"/>
@@ -10246,6 +10428,7 @@
           </a:lstStyle>
           <a:p xmlns:a="http://schemas.openxmlformats.org/drawingml/2006/main">
             <a:pPr>
+              <a:buNone/>
               <a:defRPr sz="2175" b="1">
                 <a:solidFill>
                   <a:srgbClr val="4F46E5"/>
@@ -10312,6 +10495,7 @@
           </a:lstStyle>
           <a:p xmlns:a="http://schemas.openxmlformats.org/drawingml/2006/main">
             <a:pPr>
+              <a:buNone/>
               <a:defRPr sz="2025" b="0">
                 <a:solidFill>
                   <a:srgbClr val="17243B"/>
@@ -10378,6 +10562,7 @@
           </a:lstStyle>
           <a:p xmlns:a="http://schemas.openxmlformats.org/drawingml/2006/main">
             <a:pPr>
+              <a:buNone/>
               <a:defRPr sz="2175" b="1">
                 <a:solidFill>
                   <a:srgbClr val="4F46E5"/>
@@ -10444,6 +10629,7 @@
           </a:lstStyle>
           <a:p xmlns:a="http://schemas.openxmlformats.org/drawingml/2006/main">
             <a:pPr>
+              <a:buNone/>
               <a:defRPr sz="2025" b="0">
                 <a:solidFill>
                   <a:srgbClr val="17243B"/>
@@ -10539,6 +10725,7 @@
           </a:lstStyle>
           <a:p xmlns:a="http://schemas.openxmlformats.org/drawingml/2006/main">
             <a:pPr>
+              <a:buNone/>
               <a:defRPr sz="2850" b="1">
                 <a:solidFill>
                   <a:srgbClr val="17243B"/>
@@ -10605,6 +10792,7 @@
           </a:lstStyle>
           <a:p xmlns:a="http://schemas.openxmlformats.org/drawingml/2006/main">
             <a:pPr>
+              <a:buNone/>
               <a:defRPr sz="1350" b="0">
                 <a:solidFill>
                   <a:srgbClr val="52627A"/>
@@ -10671,6 +10859,7 @@
           </a:lstStyle>
           <a:p xmlns:a="http://schemas.openxmlformats.org/drawingml/2006/main">
             <a:pPr>
+              <a:buNone/>
               <a:defRPr sz="2100" b="1">
                 <a:solidFill>
                   <a:srgbClr val="4F46E5"/>
@@ -10737,6 +10926,7 @@
           </a:lstStyle>
           <a:p xmlns:a="http://schemas.openxmlformats.org/drawingml/2006/main">
             <a:pPr>
+              <a:buNone/>
               <a:defRPr sz="2175" b="1">
                 <a:solidFill>
                   <a:srgbClr val="4F46E5"/>
@@ -10803,6 +10993,7 @@
           </a:lstStyle>
           <a:p xmlns:a="http://schemas.openxmlformats.org/drawingml/2006/main">
             <a:pPr>
+              <a:buNone/>
               <a:defRPr sz="2025" b="0">
                 <a:solidFill>
                   <a:srgbClr val="17243B"/>
@@ -10869,6 +11060,7 @@
           </a:lstStyle>
           <a:p xmlns:a="http://schemas.openxmlformats.org/drawingml/2006/main">
             <a:pPr>
+              <a:buNone/>
               <a:defRPr sz="2175" b="1">
                 <a:solidFill>
                   <a:srgbClr val="4F46E5"/>
@@ -10935,6 +11127,7 @@
           </a:lstStyle>
           <a:p xmlns:a="http://schemas.openxmlformats.org/drawingml/2006/main">
             <a:pPr>
+              <a:buNone/>
               <a:defRPr sz="2025" b="0">
                 <a:solidFill>
                   <a:srgbClr val="17243B"/>
@@ -11001,6 +11194,7 @@
           </a:lstStyle>
           <a:p xmlns:a="http://schemas.openxmlformats.org/drawingml/2006/main">
             <a:pPr>
+              <a:buNone/>
               <a:defRPr sz="2175" b="1">
                 <a:solidFill>
                   <a:srgbClr val="4F46E5"/>
@@ -11067,6 +11261,7 @@
           </a:lstStyle>
           <a:p xmlns:a="http://schemas.openxmlformats.org/drawingml/2006/main">
             <a:pPr>
+              <a:buNone/>
               <a:defRPr sz="2025" b="0">
                 <a:solidFill>
                   <a:srgbClr val="17243B"/>
@@ -11162,6 +11357,7 @@
           </a:lstStyle>
           <a:p xmlns:a="http://schemas.openxmlformats.org/drawingml/2006/main">
             <a:pPr>
+              <a:buNone/>
               <a:defRPr sz="2850" b="1">
                 <a:solidFill>
                   <a:srgbClr val="17243B"/>
@@ -11228,6 +11424,7 @@
           </a:lstStyle>
           <a:p xmlns:a="http://schemas.openxmlformats.org/drawingml/2006/main">
             <a:pPr>
+              <a:buNone/>
               <a:defRPr sz="1350" b="0">
                 <a:solidFill>
                   <a:srgbClr val="52627A"/>
@@ -11294,6 +11491,7 @@
           </a:lstStyle>
           <a:p xmlns:a="http://schemas.openxmlformats.org/drawingml/2006/main">
             <a:pPr>
+              <a:buNone/>
               <a:defRPr sz="2100" b="1">
                 <a:solidFill>
                   <a:srgbClr val="4F46E5"/>
@@ -11322,7 +11520,7 @@
           <p:cNvPr id="4" name="">
             <a:extLst xmlns:a="http://schemas.openxmlformats.org/drawingml/2006/main">
               <a:ext uri="{FF2B5EF4-FFF2-40B4-BE49-F238E27FC236}">
-                <a16:creationId xmlns:a16="http://schemas.microsoft.com/office/drawing/2014/main" id="{23685083-54D5-4A1D-BC34-0F3EF8613B59}"/>
+                <a16:creationId xmlns:a16="http://schemas.microsoft.com/office/drawing/2014/main" id="{68B0557D-1703-494D-82E6-7816930A1436}"/>
               </a:ext>
             </a:extLst>
           </p:cNvPr>
@@ -11871,6 +12069,7 @@
           </a:lstStyle>
           <a:p xmlns:a="http://schemas.openxmlformats.org/drawingml/2006/main">
             <a:pPr>
+              <a:buNone/>
               <a:defRPr sz="1950" b="0">
                 <a:solidFill>
                   <a:srgbClr val="4F46E5"/>
@@ -11937,6 +12136,7 @@
           </a:lstStyle>
           <a:p xmlns:a="http://schemas.openxmlformats.org/drawingml/2006/main">
             <a:pPr>
+              <a:buNone/>
               <a:defRPr sz="1800" b="0">
                 <a:solidFill>
                   <a:srgbClr val="17243B"/>
@@ -12032,6 +12232,7 @@
           </a:lstStyle>
           <a:p xmlns:a="http://schemas.openxmlformats.org/drawingml/2006/main">
             <a:pPr>
+              <a:buNone/>
               <a:defRPr sz="2850" b="1">
                 <a:solidFill>
                   <a:srgbClr val="17243B"/>
@@ -12098,6 +12299,7 @@
           </a:lstStyle>
           <a:p xmlns:a="http://schemas.openxmlformats.org/drawingml/2006/main">
             <a:pPr>
+              <a:buNone/>
               <a:defRPr sz="1350" b="0">
                 <a:solidFill>
                   <a:srgbClr val="52627A"/>
@@ -12164,6 +12366,7 @@
           </a:lstStyle>
           <a:p xmlns:a="http://schemas.openxmlformats.org/drawingml/2006/main">
             <a:pPr>
+              <a:buNone/>
               <a:defRPr sz="2100" b="1">
                 <a:solidFill>
                   <a:srgbClr val="4F46E5"/>
@@ -12230,6 +12433,7 @@
           </a:lstStyle>
           <a:p xmlns:a="http://schemas.openxmlformats.org/drawingml/2006/main">
             <a:pPr>
+              <a:buNone/>
               <a:defRPr sz="2175" b="1">
                 <a:solidFill>
                   <a:srgbClr val="4F46E5"/>
@@ -12296,6 +12500,7 @@
           </a:lstStyle>
           <a:p xmlns:a="http://schemas.openxmlformats.org/drawingml/2006/main">
             <a:pPr>
+              <a:buNone/>
               <a:defRPr sz="2025" b="0">
                 <a:solidFill>
                   <a:srgbClr val="17243B"/>
@@ -12362,6 +12567,7 @@
           </a:lstStyle>
           <a:p xmlns:a="http://schemas.openxmlformats.org/drawingml/2006/main">
             <a:pPr>
+              <a:buNone/>
               <a:defRPr sz="2175" b="1">
                 <a:solidFill>
                   <a:srgbClr val="4F46E5"/>
@@ -12428,6 +12634,7 @@
           </a:lstStyle>
           <a:p xmlns:a="http://schemas.openxmlformats.org/drawingml/2006/main">
             <a:pPr>
+              <a:buNone/>
               <a:defRPr sz="2025" b="0">
                 <a:solidFill>
                   <a:srgbClr val="17243B"/>
@@ -12494,6 +12701,7 @@
           </a:lstStyle>
           <a:p xmlns:a="http://schemas.openxmlformats.org/drawingml/2006/main">
             <a:pPr>
+              <a:buNone/>
               <a:defRPr sz="2175" b="1">
                 <a:solidFill>
                   <a:srgbClr val="4F46E5"/>
@@ -12560,6 +12768,7 @@
           </a:lstStyle>
           <a:p xmlns:a="http://schemas.openxmlformats.org/drawingml/2006/main">
             <a:pPr>
+              <a:buNone/>
               <a:defRPr sz="2025" b="0">
                 <a:solidFill>
                   <a:srgbClr val="17243B"/>
@@ -12655,6 +12864,7 @@
           </a:lstStyle>
           <a:p xmlns:a="http://schemas.openxmlformats.org/drawingml/2006/main">
             <a:pPr>
+              <a:buNone/>
               <a:defRPr sz="2850" b="1">
                 <a:solidFill>
                   <a:srgbClr val="17243B"/>
@@ -12721,6 +12931,7 @@
           </a:lstStyle>
           <a:p xmlns:a="http://schemas.openxmlformats.org/drawingml/2006/main">
             <a:pPr>
+              <a:buNone/>
               <a:defRPr sz="1350" b="0">
                 <a:solidFill>
                   <a:srgbClr val="52627A"/>
@@ -12787,6 +12998,7 @@
           </a:lstStyle>
           <a:p xmlns:a="http://schemas.openxmlformats.org/drawingml/2006/main">
             <a:pPr>
+              <a:buNone/>
               <a:defRPr sz="2100" b="1">
                 <a:solidFill>
                   <a:srgbClr val="4F46E5"/>
@@ -12853,6 +13065,7 @@
           </a:lstStyle>
           <a:p xmlns:a="http://schemas.openxmlformats.org/drawingml/2006/main">
             <a:pPr>
+              <a:buNone/>
               <a:defRPr sz="2175" b="1">
                 <a:solidFill>
                   <a:srgbClr val="4F46E5"/>
@@ -12919,6 +13132,7 @@
           </a:lstStyle>
           <a:p xmlns:a="http://schemas.openxmlformats.org/drawingml/2006/main">
             <a:pPr>
+              <a:buNone/>
               <a:defRPr sz="2025" b="0">
                 <a:solidFill>
                   <a:srgbClr val="17243B"/>
@@ -12985,6 +13199,7 @@
           </a:lstStyle>
           <a:p xmlns:a="http://schemas.openxmlformats.org/drawingml/2006/main">
             <a:pPr>
+              <a:buNone/>
               <a:defRPr sz="2175" b="1">
                 <a:solidFill>
                   <a:srgbClr val="4F46E5"/>
@@ -13051,6 +13266,7 @@
           </a:lstStyle>
           <a:p xmlns:a="http://schemas.openxmlformats.org/drawingml/2006/main">
             <a:pPr>
+              <a:buNone/>
               <a:defRPr sz="2025" b="0">
                 <a:solidFill>
                   <a:srgbClr val="17243B"/>
@@ -13117,6 +13333,7 @@
           </a:lstStyle>
           <a:p xmlns:a="http://schemas.openxmlformats.org/drawingml/2006/main">
             <a:pPr>
+              <a:buNone/>
               <a:defRPr sz="2175" b="1">
                 <a:solidFill>
                   <a:srgbClr val="4F46E5"/>
@@ -13183,6 +13400,7 @@
           </a:lstStyle>
           <a:p xmlns:a="http://schemas.openxmlformats.org/drawingml/2006/main">
             <a:pPr>
+              <a:buNone/>
               <a:defRPr sz="2025" b="0">
                 <a:solidFill>
                   <a:srgbClr val="17243B"/>
@@ -13278,6 +13496,7 @@
           </a:lstStyle>
           <a:p xmlns:a="http://schemas.openxmlformats.org/drawingml/2006/main">
             <a:pPr>
+              <a:buNone/>
               <a:defRPr sz="2850" b="1">
                 <a:solidFill>
                   <a:srgbClr val="17243B"/>
@@ -13344,6 +13563,7 @@
           </a:lstStyle>
           <a:p xmlns:a="http://schemas.openxmlformats.org/drawingml/2006/main">
             <a:pPr>
+              <a:buNone/>
               <a:defRPr sz="1350" b="0">
                 <a:solidFill>
                   <a:srgbClr val="52627A"/>
@@ -13410,6 +13630,7 @@
           </a:lstStyle>
           <a:p xmlns:a="http://schemas.openxmlformats.org/drawingml/2006/main">
             <a:pPr>
+              <a:buNone/>
               <a:defRPr sz="2100" b="1">
                 <a:solidFill>
                   <a:srgbClr val="4F46E5"/>
@@ -13476,6 +13697,7 @@
           </a:lstStyle>
           <a:p xmlns:a="http://schemas.openxmlformats.org/drawingml/2006/main">
             <a:pPr>
+              <a:buNone/>
               <a:defRPr sz="2175" b="1">
                 <a:solidFill>
                   <a:srgbClr val="4F46E5"/>
@@ -13542,6 +13764,7 @@
           </a:lstStyle>
           <a:p xmlns:a="http://schemas.openxmlformats.org/drawingml/2006/main">
             <a:pPr>
+              <a:buNone/>
               <a:defRPr sz="2025" b="0">
                 <a:solidFill>
                   <a:srgbClr val="17243B"/>
@@ -13608,6 +13831,7 @@
           </a:lstStyle>
           <a:p xmlns:a="http://schemas.openxmlformats.org/drawingml/2006/main">
             <a:pPr>
+              <a:buNone/>
               <a:defRPr sz="2175" b="1">
                 <a:solidFill>
                   <a:srgbClr val="4F46E5"/>
@@ -13674,6 +13898,7 @@
           </a:lstStyle>
           <a:p xmlns:a="http://schemas.openxmlformats.org/drawingml/2006/main">
             <a:pPr>
+              <a:buNone/>
               <a:defRPr sz="2025" b="0">
                 <a:solidFill>
                   <a:srgbClr val="17243B"/>
@@ -13740,6 +13965,7 @@
           </a:lstStyle>
           <a:p xmlns:a="http://schemas.openxmlformats.org/drawingml/2006/main">
             <a:pPr>
+              <a:buNone/>
               <a:defRPr sz="2175" b="1">
                 <a:solidFill>
                   <a:srgbClr val="4F46E5"/>
@@ -13806,6 +14032,7 @@
           </a:lstStyle>
           <a:p xmlns:a="http://schemas.openxmlformats.org/drawingml/2006/main">
             <a:pPr>
+              <a:buNone/>
               <a:defRPr sz="2025" b="0">
                 <a:solidFill>
                   <a:srgbClr val="17243B"/>

</xml_diff>